<commit_message>
Expand morning curriculum and presentation deck to 27 slides with GenAI and AI-Native standards
</commit_message>
<xml_diff>
--- a/slides-morning/orientation-and-health-ai-foundations.pptx
+++ b/slides-morning/orientation-and-health-ai-foundations.pptx
@@ -30,6 +30,8 @@
     <p:sldId id="278" r:id="rId29"/>
     <p:sldId id="279" r:id="rId30"/>
     <p:sldId id="280" r:id="rId31"/>
+    <p:sldId id="281" r:id="rId32"/>
+    <p:sldId id="282" r:id="rId33"/>
   </p:sldIdLst>
   <p:sldSz cx="12191695" cy="6858000" type="screen4x3"/>
   <p:notesSz cx="6858000" cy="9144000"/>
@@ -3754,7 +3756,7 @@
         <p:spPr>
           <a:xfrm>
             <a:off x="822960" y="1645920"/>
-            <a:ext cx="4114800" cy="411480"/>
+            <a:ext cx="4389120" cy="411480"/>
           </a:xfrm>
           <a:prstGeom prst="roundRect">
             <a:avLst/>
@@ -3820,14 +3822,14 @@
           <a:lstStyle/>
           <a:p>
             <a:pPr>
-              <a:defRPr b="1" sz="3800">
+              <a:defRPr b="1" sz="3600">
                 <a:solidFill>
                   <a:srgbClr val="FFFFFF"/>
                 </a:solidFill>
               </a:defRPr>
             </a:pPr>
             <a:r>
-              <a:t>From HL7 v2 to FHIR R4</a:t>
+              <a:t>OSI Layer 7 &amp; The HL7 Mandate</a:t>
             </a:r>
           </a:p>
           <a:p>
@@ -3835,14 +3837,14 @@
               <a:spcBef>
                 <a:spcPts val="1200"/>
               </a:spcBef>
-              <a:defRPr sz="1700">
+              <a:defRPr sz="1600">
                 <a:solidFill>
                   <a:srgbClr val="94BA33"/>
                 </a:solidFill>
               </a:defRPr>
             </a:pPr>
             <a:r>
-              <a:t>How 35 years of medical IT evolved from 1989 serial delimiters to modern RESTful web APIs</a:t>
+              <a:t>Why networking solved moving packets (Layers 1–4), but healthcare required standardizing Application Meaning (Layer 7)</a:t>
             </a:r>
           </a:p>
         </p:txBody>
@@ -3909,7 +3911,7 @@
               </a:defRPr>
             </a:pPr>
             <a:r>
-              <a:t>In HL7 v2, you find a value by counting pipe delimiters in a line. In FHIR, you query a standardized URI endpoint and parse standard JSON.</a:t>
+              <a:t>In HL7 v2 (1989), you read a lab value by counting pipe delimiters in a line. In FHIR (2014), you query a RESTful URI endpoint and parse standard JSON.</a:t>
             </a:r>
           </a:p>
         </p:txBody>
@@ -4534,7 +4536,7 @@
               </a:defRPr>
             </a:pPr>
             <a:r>
-              <a:t>Why HL7 v2 Broke at Scale: The Integration Debt</a:t>
+              <a:t>Technological Relativity: Why HL7 v2 in 1989</a:t>
             </a:r>
           </a:p>
         </p:txBody>
@@ -4570,7 +4572,7 @@
               </a:defRPr>
             </a:pPr>
             <a:r>
-              <a:t>"When you've seen one HL7 v2 implementation... you've seen ONE implementation."</a:t>
+              <a:t>An engineering triumph for 1989 hardware that accumulated 30 years of Z-segment integration debt</a:t>
             </a:r>
           </a:p>
         </p:txBody>
@@ -4643,12 +4645,12 @@
             <a:pPr algn="ctr">
               <a:defRPr b="1" sz="1600">
                 <a:solidFill>
-                  <a:srgbClr val="C0392B"/>
-                </a:solidFill>
-              </a:defRPr>
-            </a:pPr>
-            <a:r>
-              <a:t>The 'Z-Segment' Trap</a:t>
+                  <a:srgbClr val="285C36"/>
+                </a:solidFill>
+              </a:defRPr>
+            </a:pPr>
+            <a:r>
+              <a:t>The Context of 1989</a:t>
             </a:r>
           </a:p>
           <a:p>
@@ -4663,7 +4665,7 @@
               </a:defRPr>
             </a:pPr>
             <a:r>
-              <a:t>Non-Standard Custom Extensions</a:t>
+              <a:t>Why Not JSON / REST?</a:t>
             </a:r>
           </a:p>
           <a:p>
@@ -4678,7 +4680,7 @@
               </a:defRPr>
             </a:pPr>
             <a:r>
-              <a:t>HL7 v2 was so loosely specified that vendors added proprietary custom segments (ZBE, ZPD, ZAL). A message from Hospital A could not be parsed by Hospital B without bespoke translation code.</a:t>
+              <a:t>The Web didn't exist (HTTP in 1991, JSON in 2001). Hardware was 1–4 MB RAM and 10 Mbps coax. Delimiter-separated ASCII allowed O(1) streaming directly into C buffers over raw TCP sockets without memory bloat.</a:t>
             </a:r>
           </a:p>
         </p:txBody>
@@ -4727,12 +4729,12 @@
             <a:pPr algn="ctr">
               <a:defRPr b="1" sz="1600">
                 <a:solidFill>
-                  <a:srgbClr val="285C36"/>
-                </a:solidFill>
-              </a:defRPr>
-            </a:pPr>
-            <a:r>
-              <a:t>Optionality Chaos</a:t>
+                  <a:srgbClr val="C0392B"/>
+                </a:solidFill>
+              </a:defRPr>
+            </a:pPr>
+            <a:r>
+              <a:t>The 'Z-Segment' Trap</a:t>
             </a:r>
           </a:p>
           <a:p>
@@ -4747,7 +4749,7 @@
               </a:defRPr>
             </a:pPr>
             <a:r>
-              <a:t>No Enforceable Schema</a:t>
+              <a:t>Non-Standard Custom Extensions</a:t>
             </a:r>
           </a:p>
           <a:p>
@@ -4762,7 +4764,7 @@
               </a:defRPr>
             </a:pPr>
             <a:r>
-              <a:t>Nearly every field in HL7 v2 was optional. Fields could be omitted or swapped without violating the specification. Parsers broke unpredictably on minor hospital software updates.</a:t>
+              <a:t>HL7 v2 was so loosely specified that vendors added proprietary custom segments (ZBE, ZPD, ZAL). A message from Hospital A could not be parsed by Hospital B without bespoke translation code.</a:t>
             </a:r>
           </a:p>
         </p:txBody>
@@ -4816,7 +4818,7 @@
               </a:defRPr>
             </a:pPr>
             <a:r>
-              <a:t>No Standard Web API</a:t>
+              <a:t>The Modern Debt</a:t>
             </a:r>
           </a:p>
           <a:p>
@@ -7205,7 +7207,7 @@
               </a:defRPr>
             </a:pPr>
             <a:r>
-              <a:t>The Four Pillars of AI-Readiness in Clinical Data</a:t>
+              <a:t>The New Dilemma: Is FHIR R4 Actually "AI-Ready"?</a:t>
             </a:r>
           </a:p>
         </p:txBody>
@@ -7241,7 +7243,7 @@
               </a:defRPr>
             </a:pPr>
             <a:r>
-              <a:t>Having gigabytes of healthcare records does not make them fit for machine learning</a:t>
+              <a:t>Why transactional healthcare records (OLTP) require four strict pillars to become fit for ML (OLAP)</a:t>
             </a:r>
           </a:p>
         </p:txBody>
@@ -10117,6 +10119,950 @@
 </file>
 
 <file path=ppt/slides/slide25.xml><?xml version="1.0" encoding="utf-8"?>
+<p:sld xmlns:a="http://schemas.openxmlformats.org/drawingml/2006/main" xmlns:p="http://schemas.openxmlformats.org/presentationml/2006/main" xmlns:r="http://schemas.openxmlformats.org/officeDocument/2006/relationships">
+  <p:cSld>
+    <p:spTree>
+      <p:nvGrpSpPr>
+        <p:cNvPr id="1" name=""/>
+        <p:cNvGrpSpPr/>
+        <p:nvPr/>
+      </p:nvGrpSpPr>
+      <p:grpSpPr/>
+      <p:sp>
+        <p:nvSpPr>
+          <p:cNvPr id="2" name="Rectangle 1"/>
+          <p:cNvSpPr/>
+          <p:nvPr/>
+        </p:nvSpPr>
+        <p:spPr>
+          <a:xfrm>
+            <a:off x="0" y="0"/>
+            <a:ext cx="12191695" cy="6858000"/>
+          </a:xfrm>
+          <a:prstGeom prst="rect">
+            <a:avLst/>
+          </a:prstGeom>
+          <a:solidFill>
+            <a:srgbClr val="F5F7F5"/>
+          </a:solidFill>
+          <a:ln>
+            <a:noFill/>
+          </a:ln>
+        </p:spPr>
+        <p:style>
+          <a:lnRef idx="1">
+            <a:schemeClr val="accent1"/>
+          </a:lnRef>
+          <a:fillRef idx="3">
+            <a:schemeClr val="accent1"/>
+          </a:fillRef>
+          <a:effectRef idx="2">
+            <a:schemeClr val="accent1"/>
+          </a:effectRef>
+          <a:fontRef idx="minor">
+            <a:schemeClr val="lt1"/>
+          </a:fontRef>
+        </p:style>
+        <p:txBody>
+          <a:bodyPr rtlCol="0" anchor="ctr"/>
+          <a:lstStyle/>
+          <a:p>
+            <a:pPr algn="ctr"/>
+          </a:p>
+        </p:txBody>
+      </p:sp>
+      <p:sp>
+        <p:nvSpPr>
+          <p:cNvPr id="3" name="TextBox 2"/>
+          <p:cNvSpPr txBox="1"/>
+          <p:nvPr/>
+        </p:nvSpPr>
+        <p:spPr>
+          <a:xfrm>
+            <a:off x="731520" y="365760"/>
+            <a:ext cx="7772400" cy="320040"/>
+          </a:xfrm>
+          <a:prstGeom prst="rect">
+            <a:avLst/>
+          </a:prstGeom>
+          <a:noFill/>
+        </p:spPr>
+        <p:txBody>
+          <a:bodyPr wrap="square" lIns="0" rIns="0" tIns="0" bIns="0">
+            <a:spAutoFit/>
+          </a:bodyPr>
+          <a:lstStyle/>
+          <a:p>
+            <a:pPr>
+              <a:defRPr sz="1000" b="1">
+                <a:solidFill>
+                  <a:srgbClr val="285C36"/>
+                </a:solidFill>
+                <a:latin typeface="Arial"/>
+              </a:defRPr>
+            </a:pPr>
+            <a:r>
+              <a:t>THE GENERATIVE AI ERA</a:t>
+            </a:r>
+          </a:p>
+        </p:txBody>
+      </p:sp>
+      <p:sp>
+        <p:nvSpPr>
+          <p:cNvPr id="4" name="TextBox 3"/>
+          <p:cNvSpPr txBox="1"/>
+          <p:nvPr/>
+        </p:nvSpPr>
+        <p:spPr>
+          <a:xfrm>
+            <a:off x="731520" y="658368"/>
+            <a:ext cx="8961120" cy="594360"/>
+          </a:xfrm>
+          <a:prstGeom prst="rect">
+            <a:avLst/>
+          </a:prstGeom>
+          <a:noFill/>
+        </p:spPr>
+        <p:txBody>
+          <a:bodyPr wrap="square" lIns="0" rIns="0" tIns="0" bIns="0">
+            <a:spAutoFit/>
+          </a:bodyPr>
+          <a:lstStyle/>
+          <a:p>
+            <a:pPr>
+              <a:defRPr sz="2100" b="1">
+                <a:solidFill>
+                  <a:srgbClr val="1B3E24"/>
+                </a:solidFill>
+                <a:latin typeface="Arial"/>
+              </a:defRPr>
+            </a:pPr>
+            <a:r>
+              <a:t>LLMs, Clinical Agents &amp; Context Formats</a:t>
+            </a:r>
+          </a:p>
+        </p:txBody>
+      </p:sp>
+      <p:sp>
+        <p:nvSpPr>
+          <p:cNvPr id="5" name="TextBox 4"/>
+          <p:cNvSpPr txBox="1"/>
+          <p:nvPr/>
+        </p:nvSpPr>
+        <p:spPr>
+          <a:xfrm>
+            <a:off x="731520" y="1261872"/>
+            <a:ext cx="9144000" cy="365760"/>
+          </a:xfrm>
+          <a:prstGeom prst="rect">
+            <a:avLst/>
+          </a:prstGeom>
+          <a:noFill/>
+        </p:spPr>
+        <p:txBody>
+          <a:bodyPr wrap="square" lIns="0" rIns="0" tIns="0" bIns="0">
+            <a:spAutoFit/>
+          </a:bodyPr>
+          <a:lstStyle/>
+          <a:p>
+            <a:pPr>
+              <a:defRPr sz="1200">
+                <a:solidFill>
+                  <a:srgbClr val="526458"/>
+                </a:solidFill>
+                <a:latin typeface="Arial"/>
+              </a:defRPr>
+            </a:pPr>
+            <a:r>
+              <a:t>Why modern clinical AI assistants consume Markdown, RAG, and MCP rather than raw FHIR JSON</a:t>
+            </a:r>
+          </a:p>
+        </p:txBody>
+      </p:sp>
+      <p:pic>
+        <p:nvPicPr>
+          <p:cNvPr id="6" name="Picture 5" descr="ait_logo.png"/>
+          <p:cNvPicPr>
+            <a:picLocks noChangeAspect="1"/>
+          </p:cNvPicPr>
+          <p:nvPr/>
+        </p:nvPicPr>
+        <p:blipFill>
+          <a:blip r:embed="rId2"/>
+          <a:stretch>
+            <a:fillRect/>
+          </a:stretch>
+        </p:blipFill>
+        <p:spPr>
+          <a:xfrm>
+            <a:off x="10149840" y="411480"/>
+            <a:ext cx="1371600" cy="293914"/>
+          </a:xfrm>
+          <a:prstGeom prst="rect">
+            <a:avLst/>
+          </a:prstGeom>
+        </p:spPr>
+      </p:pic>
+      <p:sp>
+        <p:nvSpPr>
+          <p:cNvPr id="7" name="Rounded Rectangle 6"/>
+          <p:cNvSpPr/>
+          <p:nvPr/>
+        </p:nvSpPr>
+        <p:spPr>
+          <a:xfrm>
+            <a:off x="731520" y="1828800"/>
+            <a:ext cx="3429000" cy="4297680"/>
+          </a:xfrm>
+          <a:prstGeom prst="roundRect">
+            <a:avLst/>
+          </a:prstGeom>
+          <a:solidFill>
+            <a:srgbClr val="FFFFFF"/>
+          </a:solidFill>
+          <a:ln w="15240">
+            <a:solidFill>
+              <a:srgbClr val="D2DCD4"/>
+            </a:solidFill>
+          </a:ln>
+        </p:spPr>
+        <p:style>
+          <a:lnRef idx="1">
+            <a:schemeClr val="accent1"/>
+          </a:lnRef>
+          <a:fillRef idx="3">
+            <a:schemeClr val="accent1"/>
+          </a:fillRef>
+          <a:effectRef idx="2">
+            <a:schemeClr val="accent1"/>
+          </a:effectRef>
+          <a:fontRef idx="minor">
+            <a:schemeClr val="lt1"/>
+          </a:fontRef>
+        </p:style>
+        <p:txBody>
+          <a:bodyPr rtlCol="0" anchor="ctr" lIns="274320" rIns="274320" tIns="274320"/>
+          <a:lstStyle/>
+          <a:p>
+            <a:pPr algn="ctr">
+              <a:defRPr b="1" sz="1600">
+                <a:solidFill>
+                  <a:srgbClr val="C0392B"/>
+                </a:solidFill>
+              </a:defRPr>
+            </a:pPr>
+            <a:r>
+              <a:t>The Token Bloat Trap</a:t>
+            </a:r>
+          </a:p>
+          <a:p>
+            <a:pPr>
+              <a:spcBef>
+                <a:spcPts val="400"/>
+              </a:spcBef>
+              <a:defRPr b="1" sz="1100">
+                <a:solidFill>
+                  <a:srgbClr val="1B3E24"/>
+                </a:solidFill>
+              </a:defRPr>
+            </a:pPr>
+            <a:r>
+              <a:t>Raw FHIR in LLM Contexts</a:t>
+            </a:r>
+          </a:p>
+          <a:p>
+            <a:pPr>
+              <a:spcBef>
+                <a:spcPts val="1000"/>
+              </a:spcBef>
+              <a:defRPr sz="1050">
+                <a:solidFill>
+                  <a:srgbClr val="142118"/>
+                </a:solidFill>
+              </a:defRPr>
+            </a:pPr>
+            <a:r>
+              <a:t>A single FHIR Observation consumes 300–500 tokens of nested schema boilerplate (`resourceType`, `system`, `coding`).</a:t>
+            </a:r>
+            <a:br/>
+            <a:br/>
+            <a:r>
+              <a:t>Dumping an entire patient chart burns 50,000+ tokens, diluting clinical signal and increasing hallucination risks.</a:t>
+            </a:r>
+          </a:p>
+        </p:txBody>
+      </p:sp>
+      <p:sp>
+        <p:nvSpPr>
+          <p:cNvPr id="8" name="Rounded Rectangle 7"/>
+          <p:cNvSpPr/>
+          <p:nvPr/>
+        </p:nvSpPr>
+        <p:spPr>
+          <a:xfrm>
+            <a:off x="4343400" y="1828800"/>
+            <a:ext cx="3429000" cy="4297680"/>
+          </a:xfrm>
+          <a:prstGeom prst="roundRect">
+            <a:avLst/>
+          </a:prstGeom>
+          <a:solidFill>
+            <a:srgbClr val="FFFFFF"/>
+          </a:solidFill>
+          <a:ln w="15240">
+            <a:solidFill>
+              <a:srgbClr val="D2DCD4"/>
+            </a:solidFill>
+          </a:ln>
+        </p:spPr>
+        <p:style>
+          <a:lnRef idx="1">
+            <a:schemeClr val="accent1"/>
+          </a:lnRef>
+          <a:fillRef idx="3">
+            <a:schemeClr val="accent1"/>
+          </a:fillRef>
+          <a:effectRef idx="2">
+            <a:schemeClr val="accent1"/>
+          </a:effectRef>
+          <a:fontRef idx="minor">
+            <a:schemeClr val="lt1"/>
+          </a:fontRef>
+        </p:style>
+        <p:txBody>
+          <a:bodyPr rtlCol="0" anchor="ctr" lIns="274320" rIns="274320" tIns="274320"/>
+          <a:lstStyle/>
+          <a:p>
+            <a:pPr algn="ctr">
+              <a:defRPr b="1" sz="1600">
+                <a:solidFill>
+                  <a:srgbClr val="285C36"/>
+                </a:solidFill>
+              </a:defRPr>
+            </a:pPr>
+            <a:r>
+              <a:t>Emerging Context Formats</a:t>
+            </a:r>
+          </a:p>
+          <a:p>
+            <a:pPr>
+              <a:spcBef>
+                <a:spcPts val="400"/>
+              </a:spcBef>
+              <a:defRPr b="1" sz="1100">
+                <a:solidFill>
+                  <a:srgbClr val="1B3E24"/>
+                </a:solidFill>
+              </a:defRPr>
+            </a:pPr>
+            <a:r>
+              <a:t>Markdown &amp; Vector RAG</a:t>
+            </a:r>
+          </a:p>
+          <a:p>
+            <a:pPr>
+              <a:spcBef>
+                <a:spcPts val="1000"/>
+              </a:spcBef>
+              <a:defRPr sz="1050">
+                <a:solidFill>
+                  <a:srgbClr val="142118"/>
+                </a:solidFill>
+              </a:defRPr>
+            </a:pPr>
+            <a:r>
+              <a:t>• Markdown (.md): Transforming FHIR JSON into clean markdown tables reduces token overhead by 60–75% while boosting LLM reasoning.</a:t>
+            </a:r>
+            <a:br/>
+            <a:br/>
+            <a:r>
+              <a:t>• Clinical RAG: Semantic search over vector databases (e.g. pgvector, Chroma) retrieves relevant clinical notes and guidelines.</a:t>
+            </a:r>
+          </a:p>
+        </p:txBody>
+      </p:sp>
+      <p:sp>
+        <p:nvSpPr>
+          <p:cNvPr id="9" name="Rounded Rectangle 8"/>
+          <p:cNvSpPr/>
+          <p:nvPr/>
+        </p:nvSpPr>
+        <p:spPr>
+          <a:xfrm>
+            <a:off x="7955280" y="1828800"/>
+            <a:ext cx="3429000" cy="4297680"/>
+          </a:xfrm>
+          <a:prstGeom prst="roundRect">
+            <a:avLst/>
+          </a:prstGeom>
+          <a:solidFill>
+            <a:srgbClr val="FFFFFF"/>
+          </a:solidFill>
+          <a:ln w="15240">
+            <a:solidFill>
+              <a:srgbClr val="D2DCD4"/>
+            </a:solidFill>
+          </a:ln>
+        </p:spPr>
+        <p:style>
+          <a:lnRef idx="1">
+            <a:schemeClr val="accent1"/>
+          </a:lnRef>
+          <a:fillRef idx="3">
+            <a:schemeClr val="accent1"/>
+          </a:fillRef>
+          <a:effectRef idx="2">
+            <a:schemeClr val="accent1"/>
+          </a:effectRef>
+          <a:fontRef idx="minor">
+            <a:schemeClr val="lt1"/>
+          </a:fontRef>
+        </p:style>
+        <p:txBody>
+          <a:bodyPr rtlCol="0" anchor="ctr" lIns="274320" rIns="274320" tIns="274320"/>
+          <a:lstStyle/>
+          <a:p>
+            <a:pPr algn="ctr">
+              <a:defRPr b="1" sz="1600">
+                <a:solidFill>
+                  <a:srgbClr val="94BA33"/>
+                </a:solidFill>
+              </a:defRPr>
+            </a:pPr>
+            <a:r>
+              <a:t>Agentic Tool-Calling</a:t>
+            </a:r>
+          </a:p>
+          <a:p>
+            <a:pPr>
+              <a:spcBef>
+                <a:spcPts val="400"/>
+              </a:spcBef>
+              <a:defRPr b="1" sz="1100">
+                <a:solidFill>
+                  <a:srgbClr val="1B3E24"/>
+                </a:solidFill>
+              </a:defRPr>
+            </a:pPr>
+            <a:r>
+              <a:t>Model Context Protocol (MCP)</a:t>
+            </a:r>
+          </a:p>
+          <a:p>
+            <a:pPr>
+              <a:spcBef>
+                <a:spcPts val="1000"/>
+              </a:spcBef>
+              <a:defRPr sz="1050">
+                <a:solidFill>
+                  <a:srgbClr val="142118"/>
+                </a:solidFill>
+              </a:defRPr>
+            </a:pPr>
+            <a:r>
+              <a:t>Instead of large prompt dumps, autonomous clinical agents query structured tools on-demand:</a:t>
+            </a:r>
+            <a:br/>
+            <a:br/>
+            <a:r>
+              <a:t>• get_patient_labs(id, 'glucose')</a:t>
+            </a:r>
+            <a:br/>
+            <a:r>
+              <a:t>• check_drug_interaction(rx_a, rx_b)</a:t>
+            </a:r>
+            <a:br/>
+            <a:br/>
+            <a:r>
+              <a:t>Ensures scoped, auditable, and deterministic tool execution.</a:t>
+            </a:r>
+          </a:p>
+        </p:txBody>
+      </p:sp>
+    </p:spTree>
+  </p:cSld>
+  <p:clrMapOvr>
+    <a:masterClrMapping/>
+  </p:clrMapOvr>
+</p:sld>
+</file>
+
+<file path=ppt/slides/slide26.xml><?xml version="1.0" encoding="utf-8"?>
+<p:sld xmlns:a="http://schemas.openxmlformats.org/drawingml/2006/main" xmlns:p="http://schemas.openxmlformats.org/presentationml/2006/main" xmlns:r="http://schemas.openxmlformats.org/officeDocument/2006/relationships">
+  <p:cSld>
+    <p:spTree>
+      <p:nvGrpSpPr>
+        <p:cNvPr id="1" name=""/>
+        <p:cNvGrpSpPr/>
+        <p:nvPr/>
+      </p:nvGrpSpPr>
+      <p:grpSpPr/>
+      <p:sp>
+        <p:nvSpPr>
+          <p:cNvPr id="2" name="Rectangle 1"/>
+          <p:cNvSpPr/>
+          <p:nvPr/>
+        </p:nvSpPr>
+        <p:spPr>
+          <a:xfrm>
+            <a:off x="0" y="0"/>
+            <a:ext cx="12191695" cy="6858000"/>
+          </a:xfrm>
+          <a:prstGeom prst="rect">
+            <a:avLst/>
+          </a:prstGeom>
+          <a:solidFill>
+            <a:srgbClr val="F5F7F5"/>
+          </a:solidFill>
+          <a:ln>
+            <a:noFill/>
+          </a:ln>
+        </p:spPr>
+        <p:style>
+          <a:lnRef idx="1">
+            <a:schemeClr val="accent1"/>
+          </a:lnRef>
+          <a:fillRef idx="3">
+            <a:schemeClr val="accent1"/>
+          </a:fillRef>
+          <a:effectRef idx="2">
+            <a:schemeClr val="accent1"/>
+          </a:effectRef>
+          <a:fontRef idx="minor">
+            <a:schemeClr val="lt1"/>
+          </a:fontRef>
+        </p:style>
+        <p:txBody>
+          <a:bodyPr rtlCol="0" anchor="ctr"/>
+          <a:lstStyle/>
+          <a:p>
+            <a:pPr algn="ctr"/>
+          </a:p>
+        </p:txBody>
+      </p:sp>
+      <p:sp>
+        <p:nvSpPr>
+          <p:cNvPr id="3" name="TextBox 2"/>
+          <p:cNvSpPr txBox="1"/>
+          <p:nvPr/>
+        </p:nvSpPr>
+        <p:spPr>
+          <a:xfrm>
+            <a:off x="731520" y="365760"/>
+            <a:ext cx="7772400" cy="320040"/>
+          </a:xfrm>
+          <a:prstGeom prst="rect">
+            <a:avLst/>
+          </a:prstGeom>
+          <a:noFill/>
+        </p:spPr>
+        <p:txBody>
+          <a:bodyPr wrap="square" lIns="0" rIns="0" tIns="0" bIns="0">
+            <a:spAutoFit/>
+          </a:bodyPr>
+          <a:lstStyle/>
+          <a:p>
+            <a:pPr>
+              <a:defRPr sz="1000" b="1">
+                <a:solidFill>
+                  <a:srgbClr val="285C36"/>
+                </a:solidFill>
+                <a:latin typeface="Arial"/>
+              </a:defRPr>
+            </a:pPr>
+            <a:r>
+              <a:t>THE NEXT EVOLUTION</a:t>
+            </a:r>
+          </a:p>
+        </p:txBody>
+      </p:sp>
+      <p:sp>
+        <p:nvSpPr>
+          <p:cNvPr id="4" name="TextBox 3"/>
+          <p:cNvSpPr txBox="1"/>
+          <p:nvPr/>
+        </p:nvSpPr>
+        <p:spPr>
+          <a:xfrm>
+            <a:off x="731520" y="658368"/>
+            <a:ext cx="8961120" cy="594360"/>
+          </a:xfrm>
+          <a:prstGeom prst="rect">
+            <a:avLst/>
+          </a:prstGeom>
+          <a:noFill/>
+        </p:spPr>
+        <p:txBody>
+          <a:bodyPr wrap="square" lIns="0" rIns="0" tIns="0" bIns="0">
+            <a:spAutoFit/>
+          </a:bodyPr>
+          <a:lstStyle/>
+          <a:p>
+            <a:pPr>
+              <a:defRPr sz="2100" b="1">
+                <a:solidFill>
+                  <a:srgbClr val="1B3E24"/>
+                </a:solidFill>
+                <a:latin typeface="Arial"/>
+              </a:defRPr>
+            </a:pPr>
+            <a:r>
+              <a:t>Towards AI-Native Health Data Standards</a:t>
+            </a:r>
+          </a:p>
+        </p:txBody>
+      </p:sp>
+      <p:sp>
+        <p:nvSpPr>
+          <p:cNvPr id="5" name="TextBox 4"/>
+          <p:cNvSpPr txBox="1"/>
+          <p:nvPr/>
+        </p:nvSpPr>
+        <p:spPr>
+          <a:xfrm>
+            <a:off x="731520" y="1261872"/>
+            <a:ext cx="9144000" cy="365760"/>
+          </a:xfrm>
+          <a:prstGeom prst="rect">
+            <a:avLst/>
+          </a:prstGeom>
+          <a:noFill/>
+        </p:spPr>
+        <p:txBody>
+          <a:bodyPr wrap="square" lIns="0" rIns="0" tIns="0" bIns="0">
+            <a:spAutoFit/>
+          </a:bodyPr>
+          <a:lstStyle/>
+          <a:p>
+            <a:pPr>
+              <a:defRPr sz="1200">
+                <a:solidFill>
+                  <a:srgbClr val="526458"/>
+                </a:solidFill>
+                <a:latin typeface="Arial"/>
+              </a:defRPr>
+            </a:pPr>
+            <a:r>
+              <a:t>Will healthcare need a new standard designed for machine learning and autonomous agents?</a:t>
+            </a:r>
+          </a:p>
+        </p:txBody>
+      </p:sp>
+      <p:pic>
+        <p:nvPicPr>
+          <p:cNvPr id="6" name="Picture 5" descr="ait_logo.png"/>
+          <p:cNvPicPr>
+            <a:picLocks noChangeAspect="1"/>
+          </p:cNvPicPr>
+          <p:nvPr/>
+        </p:nvPicPr>
+        <p:blipFill>
+          <a:blip r:embed="rId2"/>
+          <a:stretch>
+            <a:fillRect/>
+          </a:stretch>
+        </p:blipFill>
+        <p:spPr>
+          <a:xfrm>
+            <a:off x="10149840" y="411480"/>
+            <a:ext cx="1371600" cy="293914"/>
+          </a:xfrm>
+          <a:prstGeom prst="rect">
+            <a:avLst/>
+          </a:prstGeom>
+        </p:spPr>
+      </p:pic>
+      <p:sp>
+        <p:nvSpPr>
+          <p:cNvPr id="7" name="Rounded Rectangle 6"/>
+          <p:cNvSpPr/>
+          <p:nvPr/>
+        </p:nvSpPr>
+        <p:spPr>
+          <a:xfrm>
+            <a:off x="731520" y="1828800"/>
+            <a:ext cx="5120640" cy="4389120"/>
+          </a:xfrm>
+          <a:prstGeom prst="roundRect">
+            <a:avLst/>
+          </a:prstGeom>
+          <a:solidFill>
+            <a:srgbClr val="FFFFFF"/>
+          </a:solidFill>
+          <a:ln w="15240">
+            <a:solidFill>
+              <a:srgbClr val="D2DCD4"/>
+            </a:solidFill>
+          </a:ln>
+        </p:spPr>
+        <p:style>
+          <a:lnRef idx="1">
+            <a:schemeClr val="accent1"/>
+          </a:lnRef>
+          <a:fillRef idx="3">
+            <a:schemeClr val="accent1"/>
+          </a:fillRef>
+          <a:effectRef idx="2">
+            <a:schemeClr val="accent1"/>
+          </a:effectRef>
+          <a:fontRef idx="minor">
+            <a:schemeClr val="lt1"/>
+          </a:fontRef>
+        </p:style>
+        <p:txBody>
+          <a:bodyPr rtlCol="0" anchor="ctr" lIns="320040" rIns="320040" tIns="320040"/>
+          <a:lstStyle/>
+          <a:p>
+            <a:pPr algn="ctr">
+              <a:defRPr b="1" sz="1100">
+                <a:solidFill>
+                  <a:srgbClr val="285C36"/>
+                </a:solidFill>
+              </a:defRPr>
+            </a:pPr>
+            <a:r>
+              <a:t>THE THREE ERAS OF HEALTH DATA</a:t>
+            </a:r>
+          </a:p>
+          <a:p>
+            <a:pPr>
+              <a:spcBef>
+                <a:spcPts val="600"/>
+              </a:spcBef>
+              <a:defRPr b="1" sz="1800">
+                <a:solidFill>
+                  <a:srgbClr val="1B3E24"/>
+                </a:solidFill>
+              </a:defRPr>
+            </a:pPr>
+            <a:r>
+              <a:t>From Hardware Sockets to Autonomous Agents</a:t>
+            </a:r>
+          </a:p>
+          <a:p>
+            <a:pPr>
+              <a:spcBef>
+                <a:spcPts val="1000"/>
+              </a:spcBef>
+              <a:defRPr b="1" sz="1100">
+                <a:solidFill>
+                  <a:srgbClr val="142118"/>
+                </a:solidFill>
+              </a:defRPr>
+            </a:pPr>
+            <a:r>
+              <a:t>• Era 1: 1989–2011 (Local Machines):</a:t>
+            </a:r>
+            <a:br/>
+            <a:r>
+              <a:rPr b="0">
+                <a:solidFill>
+                  <a:srgbClr val="526458"/>
+                </a:solidFill>
+              </a:rPr>
+              <a:t>HL7 v2: Pipe-delimited ASCII strings over TCP sockets for local hospital LANs.</a:t>
+            </a:r>
+          </a:p>
+          <a:p>
+            <a:pPr>
+              <a:spcBef>
+                <a:spcPts val="1000"/>
+              </a:spcBef>
+              <a:defRPr b="1" sz="1100">
+                <a:solidFill>
+                  <a:srgbClr val="142118"/>
+                </a:solidFill>
+              </a:defRPr>
+            </a:pPr>
+            <a:r>
+              <a:t>• Era 2: 2014–2025 (Web &amp; Mobile):</a:t>
+            </a:r>
+            <a:br/>
+            <a:r>
+              <a:rPr b="0">
+                <a:solidFill>
+                  <a:srgbClr val="526458"/>
+                </a:solidFill>
+              </a:rPr>
+              <a:t>HL7 FHIR: JSON REST APIs and web standards for apps, clinicians, and portals.</a:t>
+            </a:r>
+          </a:p>
+          <a:p>
+            <a:pPr>
+              <a:spcBef>
+                <a:spcPts val="1000"/>
+              </a:spcBef>
+              <a:defRPr b="1" sz="1100">
+                <a:solidFill>
+                  <a:srgbClr val="142118"/>
+                </a:solidFill>
+              </a:defRPr>
+            </a:pPr>
+            <a:r>
+              <a:t>• Era 3: 2026+ (Artificial Intelligence):</a:t>
+            </a:r>
+            <a:br/>
+            <a:r>
+              <a:rPr b="0">
+                <a:solidFill>
+                  <a:srgbClr val="526458"/>
+                </a:solidFill>
+              </a:rPr>
+              <a:t>AI-Native Stack: Vector embeddings, token-optimized Markdown, and Agentic MCP tool protocols.</a:t>
+            </a:r>
+          </a:p>
+        </p:txBody>
+      </p:sp>
+      <p:sp>
+        <p:nvSpPr>
+          <p:cNvPr id="8" name="Rounded Rectangle 7"/>
+          <p:cNvSpPr/>
+          <p:nvPr/>
+        </p:nvSpPr>
+        <p:spPr>
+          <a:xfrm>
+            <a:off x="6217920" y="1828800"/>
+            <a:ext cx="5212080" cy="4389120"/>
+          </a:xfrm>
+          <a:prstGeom prst="roundRect">
+            <a:avLst/>
+          </a:prstGeom>
+          <a:solidFill>
+            <a:srgbClr val="FFFFFF"/>
+          </a:solidFill>
+          <a:ln w="15240">
+            <a:solidFill>
+              <a:srgbClr val="D2DCD4"/>
+            </a:solidFill>
+          </a:ln>
+        </p:spPr>
+        <p:style>
+          <a:lnRef idx="1">
+            <a:schemeClr val="accent1"/>
+          </a:lnRef>
+          <a:fillRef idx="3">
+            <a:schemeClr val="accent1"/>
+          </a:fillRef>
+          <a:effectRef idx="2">
+            <a:schemeClr val="accent1"/>
+          </a:effectRef>
+          <a:fontRef idx="minor">
+            <a:schemeClr val="lt1"/>
+          </a:fontRef>
+        </p:style>
+        <p:txBody>
+          <a:bodyPr rtlCol="0" anchor="ctr" lIns="320040" rIns="320040" tIns="320040"/>
+          <a:lstStyle/>
+          <a:p>
+            <a:pPr algn="ctr">
+              <a:defRPr b="1" sz="1100">
+                <a:solidFill>
+                  <a:srgbClr val="94BA33"/>
+                </a:solidFill>
+              </a:defRPr>
+            </a:pPr>
+            <a:r>
+              <a:t>THE EMERGING SOLUTION</a:t>
+            </a:r>
+          </a:p>
+          <a:p>
+            <a:pPr>
+              <a:spcBef>
+                <a:spcPts val="600"/>
+              </a:spcBef>
+              <a:defRPr b="1" sz="1800">
+                <a:solidFill>
+                  <a:srgbClr val="1B3E24"/>
+                </a:solidFill>
+              </a:defRPr>
+            </a:pPr>
+            <a:r>
+              <a:t>The Dual-Stack Health Architecture</a:t>
+            </a:r>
+          </a:p>
+          <a:p>
+            <a:pPr>
+              <a:spcBef>
+                <a:spcPts val="1000"/>
+              </a:spcBef>
+              <a:defRPr b="1" sz="1100">
+                <a:solidFill>
+                  <a:srgbClr val="142118"/>
+                </a:solidFill>
+              </a:defRPr>
+            </a:pPr>
+            <a:r>
+              <a:t>• Layer A · System of Record (FHIR):</a:t>
+            </a:r>
+            <a:br/>
+            <a:r>
+              <a:rPr b="0">
+                <a:solidFill>
+                  <a:srgbClr val="526458"/>
+                </a:solidFill>
+              </a:rPr>
+              <a:t>FHIR remains the authoritative, legally audited, and human-verified patient ledger for billing, medication safety, and clinical charts.</a:t>
+            </a:r>
+          </a:p>
+          <a:p>
+            <a:pPr>
+              <a:spcBef>
+                <a:spcPts val="1000"/>
+              </a:spcBef>
+              <a:defRPr b="1" sz="1100">
+                <a:solidFill>
+                  <a:srgbClr val="142118"/>
+                </a:solidFill>
+              </a:defRPr>
+            </a:pPr>
+            <a:r>
+              <a:t>• Layer B · System of Intelligence (AI Store):</a:t>
+            </a:r>
+            <a:br/>
+            <a:r>
+              <a:rPr b="0">
+                <a:solidFill>
+                  <a:srgbClr val="526458"/>
+                </a:solidFill>
+              </a:rPr>
+              <a:t>High-performance vector stores and feature stores (e.g. Feast, pgvector) continuously ingest FHIR streams, serving ML models and LLM agents in milliseconds.</a:t>
+            </a:r>
+          </a:p>
+          <a:p>
+            <a:pPr>
+              <a:spcBef>
+                <a:spcPts val="1000"/>
+              </a:spcBef>
+              <a:defRPr b="1" sz="1100">
+                <a:solidFill>
+                  <a:srgbClr val="142118"/>
+                </a:solidFill>
+              </a:defRPr>
+            </a:pPr>
+            <a:r>
+              <a:t>• Health MCP Protocol Standard:</a:t>
+            </a:r>
+            <a:br/>
+            <a:r>
+              <a:rPr b="0">
+                <a:solidFill>
+                  <a:srgbClr val="526458"/>
+                </a:solidFill>
+              </a:rPr>
+              <a:t>Standardizing tool schemas so any clinical AI agent can query and propose treatment orders across any hospital safely.</a:t>
+            </a:r>
+          </a:p>
+        </p:txBody>
+      </p:sp>
+    </p:spTree>
+  </p:cSld>
+  <p:clrMapOvr>
+    <a:masterClrMapping/>
+  </p:clrMapOvr>
+</p:sld>
+</file>
+
+<file path=ppt/slides/slide27.xml><?xml version="1.0" encoding="utf-8"?>
 <p:sld xmlns:a="http://schemas.openxmlformats.org/drawingml/2006/main" xmlns:p="http://schemas.openxmlformats.org/presentationml/2006/main" xmlns:r="http://schemas.openxmlformats.org/officeDocument/2006/relationships">
   <p:cSld>
     <p:spTree>

</xml_diff>